<commit_message>
clean up language about time available to build MVP.
</commit_message>
<xml_diff>
--- a/lectures/Session06-Convergence.pptx
+++ b/lectures/Session06-Convergence.pptx
@@ -5426,7 +5426,7 @@
                 <a:ea typeface="Calibri" pitchFamily="34" charset="-122"/>
                 <a:cs typeface="Calibri" pitchFamily="34" charset="-120"/>
               </a:rPr>
-              <a:t>Is there a vertical slice you could ship at ~10 hrs/week?</a:t>
+              <a:t>Is there a vertical slice you could ship in ~5 build weeks?</a:t>
             </a:r>
             <a:endParaRPr lang="en-US" sz="1250" dirty="0"/>
           </a:p>
@@ -14283,7 +14283,7 @@
                           <a:ea typeface="Calibri" pitchFamily="34" charset="-122"/>
                           <a:cs typeface="Calibri" pitchFamily="34" charset="-120"/>
                         </a:rPr>
-                        <a:t>A coherent vertical slice fits ~10 hrs/week over 14 weeks.</a:t>
+                        <a:t>A coherent vertical slice fits the real build window — about five weeks.</a:t>
                       </a:r>
                       <a:endParaRPr lang="en-US" sz="1400" dirty="0">
                         <a:latin typeface="Calibri" charset="0"/>

</xml_diff>